<commit_message>
Update official PPTX deck with 2-column layout and embedded charts
</commit_message>
<xml_diff>
--- a/TeamID_TeamName_P01.pptx
+++ b/TeamID_TeamName_P01.pptx
@@ -5961,7 +5961,7 @@
               <a:buNone/>
             </a:pPr>
             <a:r>
-              <a:rPr sz="1350" b="1">
+              <a:rPr sz="1300" b="1">
                 <a:solidFill>
                   <a:srgbClr val="351C75"/>
                 </a:solidFill>
@@ -5970,7 +5970,7 @@
               <a:t>Team Name:           </a:t>
             </a:r>
             <a:r>
-              <a:rPr sz="1350" b="0">
+              <a:rPr sz="1300" b="0">
                 <a:solidFill>
                   <a:srgbClr val="1F2429"/>
                 </a:solidFill>
@@ -5995,7 +5995,7 @@
               </a:spcAft>
             </a:pPr>
             <a:r>
-              <a:rPr sz="1350" b="1">
+              <a:rPr sz="1300" b="1">
                 <a:solidFill>
                   <a:srgbClr val="351C75"/>
                 </a:solidFill>
@@ -6004,7 +6004,7 @@
               <a:t>Track:               </a:t>
             </a:r>
             <a:r>
-              <a:rPr sz="1350" b="0">
+              <a:rPr sz="1300" b="0">
                 <a:solidFill>
                   <a:srgbClr val="1F2429"/>
                 </a:solidFill>
@@ -6020,7 +6020,7 @@
               </a:spcAft>
             </a:pPr>
             <a:r>
-              <a:rPr sz="1350" b="1">
+              <a:rPr sz="1300" b="1">
                 <a:solidFill>
                   <a:srgbClr val="351C75"/>
                 </a:solidFill>
@@ -6029,7 +6029,7 @@
               <a:t>Problem Statement:   </a:t>
             </a:r>
             <a:r>
-              <a:rPr sz="1350" b="1">
+              <a:rPr sz="1300" b="1">
                 <a:solidFill>
                   <a:srgbClr val="1F2429"/>
                 </a:solidFill>
@@ -6045,7 +6045,7 @@
               </a:spcAft>
             </a:pPr>
             <a:r>
-              <a:rPr sz="1350" b="1">
+              <a:rPr sz="1300" b="1">
                 <a:solidFill>
                   <a:srgbClr val="351C75"/>
                 </a:solidFill>
@@ -6054,7 +6054,7 @@
               <a:t>Solution Title:      </a:t>
             </a:r>
             <a:r>
-              <a:rPr sz="1350" b="1">
+              <a:rPr sz="1300" b="1">
                 <a:solidFill>
                   <a:srgbClr val="1F2429"/>
                 </a:solidFill>
@@ -6070,7 +6070,7 @@
               </a:spcAft>
             </a:pPr>
             <a:r>
-              <a:rPr sz="1350" b="1">
+              <a:rPr sz="1300" b="1">
                 <a:solidFill>
                   <a:srgbClr val="351C75"/>
                 </a:solidFill>
@@ -6079,7 +6079,7 @@
               <a:t>Team Members:        </a:t>
             </a:r>
             <a:r>
-              <a:rPr sz="1350" b="0">
+              <a:rPr sz="1300" b="0">
                 <a:solidFill>
                   <a:srgbClr val="1F2429"/>
                 </a:solidFill>
@@ -6095,7 +6095,7 @@
               </a:spcAft>
             </a:pPr>
             <a:r>
-              <a:rPr sz="1350" b="1">
+              <a:rPr sz="1300" b="1">
                 <a:solidFill>
                   <a:srgbClr val="351C75"/>
                 </a:solidFill>
@@ -6104,13 +6104,13 @@
               <a:t>Working Prototype:   </a:t>
             </a:r>
             <a:r>
-              <a:rPr sz="1350" b="0">
+              <a:rPr sz="1300" b="0">
                 <a:solidFill>
                   <a:srgbClr val="16754C"/>
                 </a:solidFill>
                 <a:latin typeface="Calibri"/>
               </a:rPr>
-              <a:t>https://github.com/tanishkuvar11/Vanishing-Dose (Live Demo: http://localhost:5173/simulator)</a:t>
+              <a:t>https://github.com/tanishkuvar11/Vanishing-Dose  (Live Demo: http://localhost:5173/simulator)</a:t>
             </a:r>
           </a:p>
           <a:p>
@@ -6120,7 +6120,7 @@
               </a:spcAft>
             </a:pPr>
             <a:r>
-              <a:rPr sz="1350" b="1">
+              <a:rPr sz="1300" b="1">
                 <a:solidFill>
                   <a:srgbClr val="351C75"/>
                 </a:solidFill>
@@ -6129,7 +6129,7 @@
               <a:t>Evaluation Target:   </a:t>
             </a:r>
             <a:r>
-              <a:rPr sz="1350" b="0">
+              <a:rPr sz="1300" b="0">
                 <a:solidFill>
                   <a:srgbClr val="1F2429"/>
                 </a:solidFill>
@@ -6239,15 +6239,15 @@
         </p:nvSpPr>
         <p:spPr>
           <a:xfrm>
-            <a:off x="311700" y="1152475"/>
-            <a:ext cx="8520600" cy="3416400"/>
+            <a:off x="365760" y="1024128"/>
+            <a:ext cx="3977639" cy="3840480"/>
           </a:xfrm>
           <a:prstGeom prst="rect">
             <a:avLst/>
           </a:prstGeom>
         </p:spPr>
         <p:txBody>
-          <a:bodyPr anchorCtr="0" anchor="t" lIns="182880" spcFirstLastPara="1" rIns="182880" wrap="square">
+          <a:bodyPr anchorCtr="0" anchor="t" lIns="45720" spcFirstLastPara="1" rIns="45720" wrap="square">
             <a:normAutofit/>
           </a:bodyPr>
           <a:lstStyle/>
@@ -6262,7 +6262,7 @@
               <a:buNone/>
             </a:pPr>
             <a:r>
-              <a:rPr sz="1100" b="1">
+              <a:rPr sz="950" b="1">
                 <a:solidFill>
                   <a:srgbClr val="A31D24"/>
                 </a:solidFill>
@@ -6271,7 +6271,7 @@
               <a:t>[THE CLINICAL BLIND SPOT] </a:t>
             </a:r>
             <a:r>
-              <a:rPr sz="1250" b="1">
+              <a:rPr sz="950" b="1">
                 <a:solidFill>
                   <a:srgbClr val="20124D"/>
                 </a:solidFill>
@@ -6291,7 +6291,7 @@
               </a:spcAft>
             </a:pPr>
             <a:r>
-              <a:rPr sz="1050" b="1">
+              <a:rPr sz="800" b="1">
                 <a:solidFill>
                   <a:srgbClr val="1F2429"/>
                 </a:solidFill>
@@ -6300,7 +6300,7 @@
               <a:t>The Invisible Danger: </a:t>
             </a:r>
             <a:r>
-              <a:rPr sz="1050" b="0">
+              <a:rPr sz="800" b="0">
                 <a:solidFill>
                   <a:srgbClr val="4A5560"/>
                 </a:solidFill>
@@ -6319,7 +6319,7 @@
               </a:spcAft>
             </a:pPr>
             <a:r>
-              <a:rPr sz="1050" b="1">
+              <a:rPr sz="800" b="1">
                 <a:solidFill>
                   <a:srgbClr val="1F2429"/>
                 </a:solidFill>
@@ -6328,7 +6328,7 @@
               <a:t>White-Coat Adherence: </a:t>
             </a:r>
             <a:r>
-              <a:rPr sz="1050" b="0">
+              <a:rPr sz="800" b="0">
                 <a:solidFill>
                   <a:srgbClr val="4A5560"/>
                 </a:solidFill>
@@ -6340,14 +6340,14 @@
           <a:p>
             <a:pPr>
               <a:spcBef>
-                <a:spcPts val="600"/>
+                <a:spcPts val="500"/>
               </a:spcBef>
               <a:spcAft>
                 <a:spcPts val="200"/>
               </a:spcAft>
             </a:pPr>
             <a:r>
-              <a:rPr sz="1100" b="1">
+              <a:rPr sz="950" b="1">
                 <a:solidFill>
                   <a:srgbClr val="351C75"/>
                 </a:solidFill>
@@ -6356,7 +6356,7 @@
               <a:t>[MULTI-SIGNAL TELEMETRY] </a:t>
             </a:r>
             <a:r>
-              <a:rPr sz="1250" b="1">
+              <a:rPr sz="950" b="1">
                 <a:solidFill>
                   <a:srgbClr val="20124D"/>
                 </a:solidFill>
@@ -6375,7 +6375,7 @@
               </a:spcAft>
             </a:pPr>
             <a:r>
-              <a:rPr sz="1050" b="1">
+              <a:rPr sz="800" b="1">
                 <a:solidFill>
                   <a:srgbClr val="1F2429"/>
                 </a:solidFill>
@@ -6384,7 +6384,7 @@
               <a:t>Three Independent Streams: </a:t>
             </a:r>
             <a:r>
-              <a:rPr sz="1050" b="0">
+              <a:rPr sz="800" b="0">
                 <a:solidFill>
                   <a:srgbClr val="4A5560"/>
                 </a:solidFill>
@@ -6403,7 +6403,7 @@
               </a:spcAft>
             </a:pPr>
             <a:r>
-              <a:rPr sz="1050" b="1">
+              <a:rPr sz="800" b="1">
                 <a:solidFill>
                   <a:srgbClr val="1F2429"/>
                 </a:solidFill>
@@ -6412,7 +6412,7 @@
               <a:t>Inconsistency Reasoner: </a:t>
             </a:r>
             <a:r>
-              <a:rPr sz="1050" b="0">
+              <a:rPr sz="800" b="0">
                 <a:solidFill>
                   <a:srgbClr val="4A5560"/>
                 </a:solidFill>
@@ -6424,14 +6424,14 @@
           <a:p>
             <a:pPr>
               <a:spcBef>
-                <a:spcPts val="600"/>
+                <a:spcPts val="500"/>
               </a:spcBef>
               <a:spcAft>
                 <a:spcPts val="200"/>
               </a:spcAft>
             </a:pPr>
             <a:r>
-              <a:rPr sz="1100" b="1">
+              <a:rPr sz="950" b="1">
                 <a:solidFill>
                   <a:srgbClr val="16754C"/>
                 </a:solidFill>
@@ -6440,7 +6440,7 @@
               <a:t>[PROTOTYPE BONUS (CRITERION 8.6)] </a:t>
             </a:r>
             <a:r>
-              <a:rPr sz="1250" b="1">
+              <a:rPr sz="950" b="1">
                 <a:solidFill>
                   <a:srgbClr val="20124D"/>
                 </a:solidFill>
@@ -6459,7 +6459,7 @@
               </a:spcAft>
             </a:pPr>
             <a:r>
-              <a:rPr sz="1050" b="1">
+              <a:rPr sz="800" b="1">
                 <a:solidFill>
                   <a:srgbClr val="1F2429"/>
                 </a:solidFill>
@@ -6468,7 +6468,7 @@
               <a:t>Live Interactive Sandbox: </a:t>
             </a:r>
             <a:r>
-              <a:rPr sz="1050" b="0">
+              <a:rPr sz="800" b="0">
                 <a:solidFill>
                   <a:srgbClr val="4A5560"/>
                 </a:solidFill>
@@ -6487,7 +6487,7 @@
               </a:spcAft>
             </a:pPr>
             <a:r>
-              <a:rPr sz="1050" b="1">
+              <a:rPr sz="800" b="1">
                 <a:solidFill>
                   <a:srgbClr val="1F2429"/>
                 </a:solidFill>
@@ -6496,7 +6496,7 @@
               <a:t>Doctor EHR Point-of-Care Screen: </a:t>
             </a:r>
             <a:r>
-              <a:rPr sz="1050" b="0">
+              <a:rPr sz="800" b="0">
                 <a:solidFill>
                   <a:srgbClr val="4A5560"/>
                 </a:solidFill>
@@ -6515,7 +6515,7 @@
               </a:spcAft>
             </a:pPr>
             <a:r>
-              <a:rPr sz="1050" b="1">
+              <a:rPr sz="800" b="1">
                 <a:solidFill>
                   <a:srgbClr val="1F2429"/>
                 </a:solidFill>
@@ -6524,7 +6524,7 @@
               <a:t>Patient Mobile Companion (CarePulse): </a:t>
             </a:r>
             <a:r>
-              <a:rPr sz="1050" b="0">
+              <a:rPr sz="800" b="0">
                 <a:solidFill>
                   <a:srgbClr val="4A5560"/>
                 </a:solidFill>
@@ -6560,6 +6560,30 @@
           <a:ln>
             <a:noFill/>
           </a:ln>
+        </p:spPr>
+      </p:pic>
+      <p:pic>
+        <p:nvPicPr>
+          <p:cNvPr id="64" name="Picture 63" descr="slide2_multi_signal_triangulation.png"/>
+          <p:cNvPicPr>
+            <a:picLocks noChangeAspect="1"/>
+          </p:cNvPicPr>
+          <p:nvPr/>
+        </p:nvPicPr>
+        <p:blipFill>
+          <a:blip r:embed="rId4"/>
+          <a:stretch>
+            <a:fillRect/>
+          </a:stretch>
+        </p:blipFill>
+        <p:spPr>
+          <a:xfrm>
+            <a:off x="4480560" y="1234440"/>
+            <a:ext cx="4297680" cy="2543080"/>
+          </a:xfrm>
+          <a:prstGeom prst="rect">
+            <a:avLst/>
+          </a:prstGeom>
         </p:spPr>
       </p:pic>
     </p:spTree>
@@ -6634,15 +6658,15 @@
         </p:nvSpPr>
         <p:spPr>
           <a:xfrm>
-            <a:off x="311700" y="1152475"/>
-            <a:ext cx="8520600" cy="3416400"/>
+            <a:off x="365760" y="1024128"/>
+            <a:ext cx="3977639" cy="3840480"/>
           </a:xfrm>
           <a:prstGeom prst="rect">
             <a:avLst/>
           </a:prstGeom>
         </p:spPr>
         <p:txBody>
-          <a:bodyPr anchorCtr="0" anchor="t" lIns="182880" spcFirstLastPara="1" rIns="182880" wrap="square">
+          <a:bodyPr anchorCtr="0" anchor="t" lIns="45720" spcFirstLastPara="1" rIns="45720" wrap="square">
             <a:normAutofit/>
           </a:bodyPr>
           <a:lstStyle/>
@@ -6657,22 +6681,22 @@
               <a:buNone/>
             </a:pPr>
             <a:r>
-              <a:rPr sz="1100" b="1">
+              <a:rPr sz="950" b="1">
                 <a:solidFill>
                   <a:srgbClr val="351C75"/>
                 </a:solidFill>
                 <a:latin typeface="Roboto Mono"/>
               </a:rPr>
-              <a:t>[DATA INGESTION &amp; PIPELINE] </a:t>
-            </a:r>
-            <a:r>
-              <a:rPr sz="1250" b="1">
+              <a:t>[DATA PIPELINE &amp; PROVENANCE] </a:t>
+            </a:r>
+            <a:r>
+              <a:rPr sz="950" b="1">
                 <a:solidFill>
                   <a:srgbClr val="20124D"/>
                 </a:solidFill>
                 <a:latin typeface="Calibri"/>
               </a:rPr>
-              <a:t>Government-Grade Claims Normalization &amp; Physiological Modeling</a:t>
+              <a:t>Government-Grade Claims Normalization &amp; Signal Modeling</a:t>
             </a:r>
             <a:endParaRPr/>
           </a:p>
@@ -6686,22 +6710,22 @@
               </a:spcAft>
             </a:pPr>
             <a:r>
-              <a:rPr sz="1050" b="1">
+              <a:rPr sz="800" b="1">
                 <a:solidFill>
                   <a:srgbClr val="1F2429"/>
                 </a:solidFill>
                 <a:latin typeface="Calibri"/>
               </a:rPr>
-              <a:t>8-Stage Pipeline: </a:t>
-            </a:r>
-            <a:r>
-              <a:rPr sz="1050" b="0">
+              <a:t>8-Stage Python Pipeline: </a:t>
+            </a:r>
+            <a:r>
+              <a:rPr sz="800" b="0">
                 <a:solidFill>
                   <a:srgbClr val="4A5560"/>
                 </a:solidFill>
                 <a:latin typeface="Calibri"/>
               </a:rPr>
-              <a:t>Built with Python, processing 116,352 real Medicare beneficiaries across 8 official CMS DE-SynPUF files. Maps National Drug Codes (NDCs) to target active ingredients via RxNorm.</a:t>
+              <a:t>Processes 116,352 real Medicare beneficiaries across 8 official CMS DE-SynPUF files. Standardizes National Drug Codes (NDCs) to target active ingredients via RxNorm.</a:t>
             </a:r>
           </a:p>
           <a:p>
@@ -6714,7 +6738,7 @@
               </a:spcAft>
             </a:pPr>
             <a:r>
-              <a:rPr sz="1050" b="1">
+              <a:rPr sz="800" b="1">
                 <a:solidFill>
                   <a:srgbClr val="1F2429"/>
                 </a:solidFill>
@@ -6723,26 +6747,26 @@
               <a:t>Rigorous Inpatient Censoring: </a:t>
             </a:r>
             <a:r>
-              <a:rPr sz="1050" b="0">
+              <a:rPr sz="800" b="0">
                 <a:solidFill>
                   <a:srgbClr val="4A5560"/>
                 </a:solidFill>
                 <a:latin typeface="Calibri"/>
               </a:rPr>
-              <a:t>Computes daily Proportion of Days Covered (PDC) while strictly censoring inpatient hospitalizations so institutional administration is never misclassified as patient non-adherence.</a:t>
+              <a:t>Computes daily Proportion of Days Covered (PDC) while strictly censoring inpatient stays so institutional care is never mislabeled as non-adherence.</a:t>
             </a:r>
           </a:p>
           <a:p>
             <a:pPr>
               <a:spcBef>
-                <a:spcPts val="600"/>
+                <a:spcPts val="500"/>
               </a:spcBef>
               <a:spcAft>
                 <a:spcPts val="200"/>
               </a:spcAft>
             </a:pPr>
             <a:r>
-              <a:rPr sz="1100" b="1">
+              <a:rPr sz="950" b="1">
                 <a:solidFill>
                   <a:srgbClr val="B87D1A"/>
                 </a:solidFill>
@@ -6751,13 +6775,13 @@
               <a:t>[SAFE AI ABSTENTION] </a:t>
             </a:r>
             <a:r>
-              <a:rPr sz="1250" b="1">
+              <a:rPr sz="950" b="1">
                 <a:solidFill>
                   <a:srgbClr val="20124D"/>
                 </a:solidFill>
                 <a:latin typeface="Calibri"/>
               </a:rPr>
-              <a:t>Split-Conformal Prediction: Distribution-Free Safety Guarantees</a:t>
+              <a:t>Split-Conformal Prediction with Finite-Sample Guarantees</a:t>
             </a:r>
           </a:p>
           <a:p>
@@ -6770,7 +6794,7 @@
               </a:spcAft>
             </a:pPr>
             <a:r>
-              <a:rPr sz="1050" b="1">
+              <a:rPr sz="800" b="1">
                 <a:solidFill>
                   <a:srgbClr val="1F2429"/>
                 </a:solidFill>
@@ -6779,7 +6803,7 @@
               <a:t>Eliminating AI Hallucination: </a:t>
             </a:r>
             <a:r>
-              <a:rPr sz="1050" b="0">
+              <a:rPr sz="800" b="0">
                 <a:solidFill>
                   <a:srgbClr val="4A5560"/>
                 </a:solidFill>
@@ -6798,7 +6822,7 @@
               </a:spcAft>
             </a:pPr>
             <a:r>
-              <a:rPr sz="1050" b="1">
+              <a:rPr sz="800" b="1">
                 <a:solidFill>
                   <a:srgbClr val="1F2429"/>
                 </a:solidFill>
@@ -6807,26 +6831,26 @@
               <a:t>Safe Refusal to Predict: </a:t>
             </a:r>
             <a:r>
-              <a:rPr sz="1050" b="0">
+              <a:rPr sz="800" b="0">
                 <a:solidFill>
                   <a:srgbClr val="4A5560"/>
                 </a:solidFill>
                 <a:latin typeface="Calibri"/>
               </a:rPr>
-              <a:t>When a patient has sparse fill history (&lt;4 refills), prediction interval margins exceed +/- 35%. The AI safely withholds judgment and prompts the doctor for pharmacy verification.</a:t>
+              <a:t>When a patient has sparse refill history (&lt;4 refills), prediction interval margins exceed +/- 35%. The AI safely withholds judgment and prompts doctor review.</a:t>
             </a:r>
           </a:p>
           <a:p>
             <a:pPr>
               <a:spcBef>
-                <a:spcPts val="600"/>
+                <a:spcPts val="500"/>
               </a:spcBef>
               <a:spcAft>
                 <a:spcPts val="200"/>
               </a:spcAft>
             </a:pPr>
             <a:r>
-              <a:rPr sz="1100" b="1">
+              <a:rPr sz="950" b="1">
                 <a:solidFill>
                   <a:srgbClr val="16754C"/>
                 </a:solidFill>
@@ -6835,13 +6859,13 @@
               <a:t>[ARCHETYPES &amp; SYSTEMS INTEGRATION] </a:t>
             </a:r>
             <a:r>
-              <a:rPr sz="1250" b="1">
+              <a:rPr sz="950" b="1">
                 <a:solidFill>
                   <a:srgbClr val="20124D"/>
                 </a:solidFill>
                 <a:latin typeface="Calibri"/>
               </a:rPr>
-              <a:t>Unsupervised Behavioral Clustering &amp; Hospital EHR Standards</a:t>
+              <a:t>Behavioral Clustering &amp; Hospital Standards</a:t>
             </a:r>
           </a:p>
           <a:p>
@@ -6854,7 +6878,7 @@
               </a:spcAft>
             </a:pPr>
             <a:r>
-              <a:rPr sz="1050" b="1">
+              <a:rPr sz="800" b="1">
                 <a:solidFill>
                   <a:srgbClr val="1F2429"/>
                 </a:solidFill>
@@ -6863,7 +6887,7 @@
               <a:t>GMM Clustering: </a:t>
             </a:r>
             <a:r>
-              <a:rPr sz="1050" b="0">
+              <a:rPr sz="800" b="0">
                 <a:solidFill>
                   <a:srgbClr val="4A5560"/>
                 </a:solidFill>
@@ -6882,7 +6906,7 @@
               </a:spcAft>
             </a:pPr>
             <a:r>
-              <a:rPr sz="1050" b="1">
+              <a:rPr sz="800" b="1">
                 <a:solidFill>
                   <a:srgbClr val="1F2429"/>
                 </a:solidFill>
@@ -6891,13 +6915,13 @@
               <a:t>SMART on FHIR &amp; CDS Hooks: </a:t>
             </a:r>
             <a:r>
-              <a:rPr sz="1050" b="0">
+              <a:rPr sz="800" b="0">
                 <a:solidFill>
                   <a:srgbClr val="4A5560"/>
                 </a:solidFill>
                 <a:latin typeface="Calibri"/>
               </a:rPr>
-              <a:t>Architected around HL7 FHIR US Core and CDS Hooks specifications for plug-and-play integration into Epic Hyperspace, Cerner Millennium, and ambulatory EHR systems.</a:t>
+              <a:t>Architected around HL7 FHIR US Core specifications for plug-and-play integration into Epic Hyperspace, Cerner Millennium, and ambulatory EHR systems.</a:t>
             </a:r>
           </a:p>
         </p:txBody>
@@ -6927,6 +6951,30 @@
           <a:ln>
             <a:noFill/>
           </a:ln>
+        </p:spPr>
+      </p:pic>
+      <p:pic>
+        <p:nvPicPr>
+          <p:cNvPr id="71" name="Picture 70" descr="slide3_split_conformal_abstention.png"/>
+          <p:cNvPicPr>
+            <a:picLocks noChangeAspect="1"/>
+          </p:cNvPicPr>
+          <p:nvPr/>
+        </p:nvPicPr>
+        <p:blipFill>
+          <a:blip r:embed="rId4"/>
+          <a:stretch>
+            <a:fillRect/>
+          </a:stretch>
+        </p:blipFill>
+        <p:spPr>
+          <a:xfrm>
+            <a:off x="4480560" y="1234440"/>
+            <a:ext cx="4297680" cy="2393645"/>
+          </a:xfrm>
+          <a:prstGeom prst="rect">
+            <a:avLst/>
+          </a:prstGeom>
         </p:spPr>
       </p:pic>
     </p:spTree>
@@ -7001,15 +7049,15 @@
         </p:nvSpPr>
         <p:spPr>
           <a:xfrm>
-            <a:off x="311700" y="1152475"/>
-            <a:ext cx="8520600" cy="3416400"/>
+            <a:off x="365760" y="1024128"/>
+            <a:ext cx="3977639" cy="3840480"/>
           </a:xfrm>
           <a:prstGeom prst="rect">
             <a:avLst/>
           </a:prstGeom>
         </p:spPr>
         <p:txBody>
-          <a:bodyPr anchorCtr="0" anchor="t" lIns="182880" spcFirstLastPara="1" rIns="182880" wrap="square">
+          <a:bodyPr anchorCtr="0" anchor="t" lIns="45720" spcFirstLastPara="1" rIns="45720" wrap="square">
             <a:normAutofit/>
           </a:bodyPr>
           <a:lstStyle/>
@@ -7024,22 +7072,22 @@
               <a:buNone/>
             </a:pPr>
             <a:r>
-              <a:rPr sz="1100" b="1">
+              <a:rPr sz="950" b="1">
                 <a:solidFill>
                   <a:srgbClr val="351C75"/>
                 </a:solidFill>
                 <a:latin typeface="Roboto Mono"/>
               </a:rPr>
-              <a:t>[CLINICAL PRACTICALITY] </a:t>
-            </a:r>
-            <a:r>
-              <a:rPr sz="1250" b="1">
+              <a:t>[POINT-OF-CARE FIT] </a:t>
+            </a:r>
+            <a:r>
+              <a:rPr sz="950" b="1">
                 <a:solidFill>
                   <a:srgbClr val="20124D"/>
                 </a:solidFill>
                 <a:latin typeface="Calibri"/>
               </a:rPr>
-              <a:t>Seamless 15-Second Doctor Workflow with Zero Hardware Burden</a:t>
+              <a:t>15-Second Doctor Workflow with Zero Hardware Cost</a:t>
             </a:r>
             <a:endParaRPr/>
           </a:p>
@@ -7053,7 +7101,7 @@
               </a:spcAft>
             </a:pPr>
             <a:r>
-              <a:rPr sz="1050" b="1">
+              <a:rPr sz="800" b="1">
                 <a:solidFill>
                   <a:srgbClr val="1F2429"/>
                 </a:solidFill>
@@ -7062,7 +7110,7 @@
               <a:t>Zero Dedicated Hardware: </a:t>
             </a:r>
             <a:r>
-              <a:rPr sz="1050" b="0">
+              <a:rPr sz="800" b="0">
                 <a:solidFill>
                   <a:srgbClr val="4A5560"/>
                 </a:solidFill>
@@ -7081,35 +7129,35 @@
               </a:spcAft>
             </a:pPr>
             <a:r>
-              <a:rPr sz="1050" b="1">
+              <a:rPr sz="800" b="1">
                 <a:solidFill>
                   <a:srgbClr val="1F2429"/>
                 </a:solidFill>
                 <a:latin typeface="Calibri"/>
               </a:rPr>
-              <a:t>15-Second Point-of-Care Actions: </a:t>
-            </a:r>
-            <a:r>
-              <a:rPr sz="1050" b="0">
+              <a:t>15-Second Doctor Actions: </a:t>
+            </a:r>
+            <a:r>
+              <a:rPr sz="800" b="0">
                 <a:solidFill>
                   <a:srgbClr val="4A5560"/>
                 </a:solidFill>
                 <a:latin typeface="Calibri"/>
               </a:rPr>
-              <a:t>Presents actionable Clinical Decision Support directly in the EHR consultation view. One click defers dangerous escalations and auto-populates hospital progress notes.</a:t>
+              <a:t>Operates seamlessly inside the doctor consultation window. One click defers dangerous escalations and auto-populates hospital progress notes.</a:t>
             </a:r>
           </a:p>
           <a:p>
             <a:pPr>
               <a:spcBef>
-                <a:spcPts val="600"/>
+                <a:spcPts val="500"/>
               </a:spcBef>
               <a:spcAft>
                 <a:spcPts val="200"/>
               </a:spcAft>
             </a:pPr>
             <a:r>
-              <a:rPr sz="1100" b="1">
+              <a:rPr sz="950" b="1">
                 <a:solidFill>
                   <a:srgbClr val="16754C"/>
                 </a:solidFill>
@@ -7118,7 +7166,7 @@
               <a:t>[HEALTH EQUITY &amp; INCLUSIVITY] </a:t>
             </a:r>
             <a:r>
-              <a:rPr sz="1250" b="1">
+              <a:rPr sz="950" b="1">
                 <a:solidFill>
                   <a:srgbClr val="20124D"/>
                 </a:solidFill>
@@ -7137,7 +7185,7 @@
               </a:spcAft>
             </a:pPr>
             <a:r>
-              <a:rPr sz="1050" b="1">
+              <a:rPr sz="800" b="1">
                 <a:solidFill>
                   <a:srgbClr val="1F2429"/>
                 </a:solidFill>
@@ -7146,13 +7194,13 @@
               <a:t>Dismantling Patient Blame: </a:t>
             </a:r>
             <a:r>
-              <a:rPr sz="1050" b="0">
+              <a:rPr sz="800" b="0">
                 <a:solidFill>
                   <a:srgbClr val="4A5560"/>
                 </a:solidFill>
                 <a:latin typeface="Calibri"/>
               </a:rPr>
-              <a:t>Over 40% of non-adherence is caused by socio-economic friction (out-of-pocket drug costs, pharmacy deserts). Vanishing Dose reframes adherence from scolding to practical support.</a:t>
+              <a:t>Over 40% of missed refills are caused by socio-economic friction (out-of-pocket costs, pharmacy deserts). Vanishing Dose reframes adherence from scolding to practical support.</a:t>
             </a:r>
           </a:p>
           <a:p>
@@ -7165,35 +7213,35 @@
               </a:spcAft>
             </a:pPr>
             <a:r>
-              <a:rPr sz="1050" b="1">
+              <a:rPr sz="800" b="1">
                 <a:solidFill>
                   <a:srgbClr val="1F2429"/>
                 </a:solidFill>
                 <a:latin typeface="Calibri"/>
               </a:rPr>
-              <a:t>Automated Financial Assistance: </a:t>
-            </a:r>
-            <a:r>
-              <a:rPr sz="1050" b="0">
+              <a:t>Automated Financial Aid: </a:t>
+            </a:r>
+            <a:r>
+              <a:rPr sz="800" b="0">
                 <a:solidFill>
                   <a:srgbClr val="4A5560"/>
                 </a:solidFill>
                 <a:latin typeface="Calibri"/>
               </a:rPr>
-              <a:t>The patient mobile companion directly pushes $15 manufacturer co-pay discount vouchers and arranges free doorstep delivery, resolving the barrier at its root.</a:t>
+              <a:t>The patient mobile app directly pushes $15 manufacturer co-pay vouchers and arranges free doorstep delivery, resolving the barrier at its root.</a:t>
             </a:r>
           </a:p>
           <a:p>
             <a:pPr>
               <a:spcBef>
-                <a:spcPts val="600"/>
+                <a:spcPts val="500"/>
               </a:spcBef>
               <a:spcAft>
                 <a:spcPts val="200"/>
               </a:spcAft>
             </a:pPr>
             <a:r>
-              <a:rPr sz="1100" b="1">
+              <a:rPr sz="950" b="1">
                 <a:solidFill>
                   <a:srgbClr val="B87D1A"/>
                 </a:solidFill>
@@ -7202,13 +7250,13 @@
               <a:t>[EXECUTION ROADMAP] </a:t>
             </a:r>
             <a:r>
-              <a:rPr sz="1250" b="1">
+              <a:rPr sz="950" b="1">
                 <a:solidFill>
                   <a:srgbClr val="20124D"/>
                 </a:solidFill>
                 <a:latin typeface="Calibri"/>
               </a:rPr>
-              <a:t>Structured 12-Month Path to Real-World Clinical Deployment</a:t>
+              <a:t>Structured 12-Month Path to Real-World Clinical Launch</a:t>
             </a:r>
           </a:p>
           <a:p>
@@ -7221,7 +7269,7 @@
               </a:spcAft>
             </a:pPr>
             <a:r>
-              <a:rPr sz="1050" b="1">
+              <a:rPr sz="800" b="1">
                 <a:solidFill>
                   <a:srgbClr val="1F2429"/>
                 </a:solidFill>
@@ -7230,7 +7278,7 @@
               <a:t>Q1 (Validation): </a:t>
             </a:r>
             <a:r>
-              <a:rPr sz="1050" b="0">
+              <a:rPr sz="800" b="0">
                 <a:solidFill>
                   <a:srgbClr val="4A5560"/>
                 </a:solidFill>
@@ -7249,7 +7297,7 @@
               </a:spcAft>
             </a:pPr>
             <a:r>
-              <a:rPr sz="1050" b="1">
+              <a:rPr sz="800" b="1">
                 <a:solidFill>
                   <a:srgbClr val="1F2429"/>
                 </a:solidFill>
@@ -7258,13 +7306,13 @@
               <a:t>Q2 (Clinical Pilot): </a:t>
             </a:r>
             <a:r>
-              <a:rPr sz="1050" b="0">
+              <a:rPr sz="800" b="0">
                 <a:solidFill>
                   <a:srgbClr val="4A5560"/>
                 </a:solidFill>
                 <a:latin typeface="Calibri"/>
               </a:rPr>
-              <a:t>Multi-site 500-patient outpatient pilot across 3 regional hospital clinics; evaluate dose escalation avoidance and blood pressure control.</a:t>
+              <a:t>Multi-site 500-patient outpatient pilot across 3 regional hospital clinics; evaluate dose escalation avoidance.</a:t>
             </a:r>
           </a:p>
           <a:p>
@@ -7277,7 +7325,7 @@
               </a:spcAft>
             </a:pPr>
             <a:r>
-              <a:rPr sz="1050" b="1">
+              <a:rPr sz="800" b="1">
                 <a:solidFill>
                   <a:srgbClr val="1F2429"/>
                 </a:solidFill>
@@ -7286,13 +7334,13 @@
               <a:t>Q3-Q4 (Scale &amp; Regulatory): </a:t>
             </a:r>
             <a:r>
-              <a:rPr sz="1050" b="0">
+              <a:rPr sz="800" b="0">
                 <a:solidFill>
                   <a:srgbClr val="4A5560"/>
                 </a:solidFill>
                 <a:latin typeface="Calibri"/>
               </a:rPr>
-              <a:t>CE/FDA Class II SaMD documentation; Epic App Orchard marketplace launch; deployment across 5 regional hospital networks and Accountable Care Organizations (ACOs).</a:t>
+              <a:t>CE/FDA Class II SaMD documentation; Epic App Orchard launch; 5 regional hospital network deployments.</a:t>
             </a:r>
           </a:p>
         </p:txBody>
@@ -7322,6 +7370,30 @@
           <a:ln>
             <a:noFill/>
           </a:ln>
+        </p:spPr>
+      </p:pic>
+      <p:pic>
+        <p:nvPicPr>
+          <p:cNvPr id="78" name="Picture 77" descr="slide4_root_causes_and_interventions.png"/>
+          <p:cNvPicPr>
+            <a:picLocks noChangeAspect="1"/>
+          </p:cNvPicPr>
+          <p:nvPr/>
+        </p:nvPicPr>
+        <p:blipFill>
+          <a:blip r:embed="rId4"/>
+          <a:stretch>
+            <a:fillRect/>
+          </a:stretch>
+        </p:blipFill>
+        <p:spPr>
+          <a:xfrm>
+            <a:off x="4480560" y="1234440"/>
+            <a:ext cx="4297680" cy="2279797"/>
+          </a:xfrm>
+          <a:prstGeom prst="rect">
+            <a:avLst/>
+          </a:prstGeom>
         </p:spPr>
       </p:pic>
     </p:spTree>
@@ -7396,15 +7468,15 @@
         </p:nvSpPr>
         <p:spPr>
           <a:xfrm>
-            <a:off x="311700" y="1152475"/>
-            <a:ext cx="8520600" cy="3416400"/>
+            <a:off x="365760" y="1024128"/>
+            <a:ext cx="3977639" cy="3840480"/>
           </a:xfrm>
           <a:prstGeom prst="rect">
             <a:avLst/>
           </a:prstGeom>
         </p:spPr>
         <p:txBody>
-          <a:bodyPr anchorCtr="0" anchor="t" lIns="182880" spcFirstLastPara="1" rIns="182880" wrap="square">
+          <a:bodyPr anchorCtr="0" anchor="t" lIns="45720" spcFirstLastPara="1" rIns="45720" wrap="square">
             <a:normAutofit/>
           </a:bodyPr>
           <a:lstStyle/>
@@ -7419,7 +7491,7 @@
               <a:buNone/>
             </a:pPr>
             <a:r>
-              <a:rPr sz="1100" b="1">
+              <a:rPr sz="950" b="1">
                 <a:solidFill>
                   <a:srgbClr val="351C75"/>
                 </a:solidFill>
@@ -7428,13 +7500,13 @@
               <a:t>[GTM &amp; OUTREACH STRATEGY] </a:t>
             </a:r>
             <a:r>
-              <a:rPr sz="1250" b="1">
+              <a:rPr sz="950" b="1">
                 <a:solidFill>
                   <a:srgbClr val="20124D"/>
                 </a:solidFill>
                 <a:latin typeface="Calibri"/>
               </a:rPr>
-              <a:t>Dual-Stakeholder Hospital &amp; Payer Go-To-Market Execution</a:t>
+              <a:t>Dual-Stakeholder Hospital &amp; Payer Execution</a:t>
             </a:r>
             <a:endParaRPr/>
           </a:p>
@@ -7448,22 +7520,22 @@
               </a:spcAft>
             </a:pPr>
             <a:r>
-              <a:rPr sz="1050" b="1">
+              <a:rPr sz="800" b="1">
                 <a:solidFill>
                   <a:srgbClr val="1F2429"/>
                 </a:solidFill>
                 <a:latin typeface="Calibri"/>
               </a:rPr>
-              <a:t>Target Customers: </a:t>
-            </a:r>
-            <a:r>
-              <a:rPr sz="1050" b="0">
+              <a:t>Target Buyers: </a:t>
+            </a:r>
+            <a:r>
+              <a:rPr sz="800" b="0">
                 <a:solidFill>
                   <a:srgbClr val="4A5560"/>
                 </a:solidFill>
                 <a:latin typeface="Calibri"/>
               </a:rPr>
-              <a:t>1) Hospital Health Systems and Accountable Care Organizations (ACOs) penalized under the CMS Hospital Readmissions Reduction Program; 2) Medicare Advantage plans seeking higher Star Ratings.</a:t>
+              <a:t>1) Hospital Health Systems and ACOs penalized under the CMS Hospital Readmissions Reduction Program; 2) Medicare Advantage plans seeking higher Star Ratings.</a:t>
             </a:r>
           </a:p>
           <a:p>
@@ -7476,7 +7548,7 @@
               </a:spcAft>
             </a:pPr>
             <a:r>
-              <a:rPr sz="1050" b="1">
+              <a:rPr sz="800" b="1">
                 <a:solidFill>
                   <a:srgbClr val="1F2429"/>
                 </a:solidFill>
@@ -7485,41 +7557,41 @@
               <a:t>Outreach Channels: </a:t>
             </a:r>
             <a:r>
-              <a:rPr sz="1050" b="0">
+              <a:rPr sz="800" b="0">
                 <a:solidFill>
                   <a:srgbClr val="4A5560"/>
                 </a:solidFill>
                 <a:latin typeface="Calibri"/>
               </a:rPr>
-              <a:t>Direct clinical sales to Chief Medical Officers; EHR marketplace distribution (Epic App Orchard, Cerner App Gallery); peer-reviewed clinical publications at ACC and AHA cardiology conferences.</a:t>
+              <a:t>Direct clinical sales to CMOs; EHR marketplace distribution (Epic App Orchard, Cerner App Gallery); peer-reviewed papers at ACC and AHA conferences.</a:t>
             </a:r>
           </a:p>
           <a:p>
             <a:pPr>
               <a:spcBef>
-                <a:spcPts val="600"/>
+                <a:spcPts val="500"/>
               </a:spcBef>
               <a:spcAft>
                 <a:spcPts val="200"/>
               </a:spcAft>
             </a:pPr>
             <a:r>
-              <a:rPr sz="1100" b="1">
+              <a:rPr sz="950" b="1">
                 <a:solidFill>
                   <a:srgbClr val="16754C"/>
                 </a:solidFill>
                 <a:latin typeface="Roboto Mono"/>
               </a:rPr>
-              <a:t>[MONETISATION &amp; PRICING] </a:t>
-            </a:r>
-            <a:r>
-              <a:rPr sz="1250" b="1">
+              <a:t>[MONETISATION MODEL] </a:t>
+            </a:r>
+            <a:r>
+              <a:rPr sz="950" b="1">
                 <a:solidFill>
                   <a:srgbClr val="20124D"/>
                 </a:solidFill>
                 <a:latin typeface="Calibri"/>
               </a:rPr>
-              <a:t>High-Margin Enterprise SaaS with Value-Based Shared Savings</a:t>
+              <a:t>High-Margin Enterprise SaaS with Shared Savings</a:t>
             </a:r>
           </a:p>
           <a:p>
@@ -7532,7 +7604,7 @@
               </a:spcAft>
             </a:pPr>
             <a:r>
-              <a:rPr sz="1050" b="1">
+              <a:rPr sz="800" b="1">
                 <a:solidFill>
                   <a:srgbClr val="1F2429"/>
                 </a:solidFill>
@@ -7541,7 +7613,7 @@
               <a:t>Tiered SaaS Subscription: </a:t>
             </a:r>
             <a:r>
-              <a:rPr sz="1050" b="0">
+              <a:rPr sz="800" b="0">
                 <a:solidFill>
                   <a:srgbClr val="4A5560"/>
                 </a:solidFill>
@@ -7560,7 +7632,7 @@
               </a:spcAft>
             </a:pPr>
             <a:r>
-              <a:rPr sz="1050" b="1">
+              <a:rPr sz="800" b="1">
                 <a:solidFill>
                   <a:srgbClr val="1F2429"/>
                 </a:solidFill>
@@ -7569,7 +7641,7 @@
               <a:t>Shared Savings Upside: </a:t>
             </a:r>
             <a:r>
-              <a:rPr sz="1050" b="0">
+              <a:rPr sz="800" b="0">
                 <a:solidFill>
                   <a:srgbClr val="4A5560"/>
                 </a:solidFill>
@@ -7581,29 +7653,29 @@
           <a:p>
             <a:pPr>
               <a:spcBef>
-                <a:spcPts val="600"/>
+                <a:spcPts val="500"/>
               </a:spcBef>
               <a:spcAft>
                 <a:spcPts val="200"/>
               </a:spcAft>
             </a:pPr>
             <a:r>
-              <a:rPr sz="1100" b="1">
+              <a:rPr sz="950" b="1">
                 <a:solidFill>
                   <a:srgbClr val="B87D1A"/>
                 </a:solidFill>
                 <a:latin typeface="Roboto Mono"/>
               </a:rPr>
-              <a:t>[UNIT ECONOMICS &amp; HOSPITAL ROI] </a:t>
-            </a:r>
-            <a:r>
-              <a:rPr sz="1250" b="1">
+              <a:t>[HOSPITAL ROI &amp; UNIT ECONOMICS] </a:t>
+            </a:r>
+            <a:r>
+              <a:rPr sz="950" b="1">
                 <a:solidFill>
                   <a:srgbClr val="20124D"/>
                 </a:solidFill>
                 <a:latin typeface="Calibri"/>
               </a:rPr>
-              <a:t>Compelling Financial Return: Over $300,000 Saved per 1,000 Patients</a:t>
+              <a:t>Compelling Returns: $377,000 Saved per 1k Patients</a:t>
             </a:r>
           </a:p>
           <a:p>
@@ -7616,7 +7688,7 @@
               </a:spcAft>
             </a:pPr>
             <a:r>
-              <a:rPr sz="1050" b="1">
+              <a:rPr sz="800" b="1">
                 <a:solidFill>
                   <a:srgbClr val="1F2429"/>
                 </a:solidFill>
@@ -7625,13 +7697,13 @@
               <a:t>Averting $28,000 ICU Stays: </a:t>
             </a:r>
             <a:r>
-              <a:rPr sz="1050" b="0">
+              <a:rPr sz="800" b="0">
                 <a:solidFill>
                   <a:srgbClr val="4A5560"/>
                 </a:solidFill>
                 <a:latin typeface="Calibri"/>
               </a:rPr>
-              <a:t>A single adverse dose escalation leading to severe hypotension or bradycardia requires intensive care admission costing $18,000 to $28,000. Preventing just 15 events per 1,000 patients yields $300,000+ in net hospital savings.</a:t>
+              <a:t>A single adverse dose escalation leading to severe hypotension requires intensive care admission costing $18,000 to $28,000. Preventing 15 events per 1,000 patients yields $300,000+ in net savings.</a:t>
             </a:r>
           </a:p>
           <a:p>
@@ -7644,7 +7716,7 @@
               </a:spcAft>
             </a:pPr>
             <a:r>
-              <a:rPr sz="1050" b="1">
+              <a:rPr sz="800" b="1">
                 <a:solidFill>
                   <a:srgbClr val="1F2429"/>
                 </a:solidFill>
@@ -7653,13 +7725,13 @@
               <a:t>SaaS Scalability &amp; Margins: </a:t>
             </a:r>
             <a:r>
-              <a:rPr sz="1050" b="0">
+              <a:rPr sz="800" b="0">
                 <a:solidFill>
                   <a:srgbClr val="4A5560"/>
                 </a:solidFill>
                 <a:latin typeface="Calibri"/>
               </a:rPr>
-              <a:t>Pure cloud microservice architecture delivers 82% gross margins, rapid hospital onboarding in under 2 weeks, and estimated LTV:CAC exceeding 5.2x.</a:t>
+              <a:t>Pure cloud microservice architecture delivers 82% gross margins, rapid hospital onboarding (&lt;2 weeks), and estimated LTV:CAC &gt; 5.2x.</a:t>
             </a:r>
           </a:p>
         </p:txBody>
@@ -7689,6 +7761,30 @@
           <a:ln>
             <a:noFill/>
           </a:ln>
+        </p:spPr>
+      </p:pic>
+      <p:pic>
+        <p:nvPicPr>
+          <p:cNvPr id="85" name="Picture 84" descr="slide5_hospital_roi_savings.png"/>
+          <p:cNvPicPr>
+            <a:picLocks noChangeAspect="1"/>
+          </p:cNvPicPr>
+          <p:nvPr/>
+        </p:nvPicPr>
+        <p:blipFill>
+          <a:blip r:embed="rId4"/>
+          <a:stretch>
+            <a:fillRect/>
+          </a:stretch>
+        </p:blipFill>
+        <p:spPr>
+          <a:xfrm>
+            <a:off x="4480560" y="1234440"/>
+            <a:ext cx="4297680" cy="2420572"/>
+          </a:xfrm>
+          <a:prstGeom prst="rect">
+            <a:avLst/>
+          </a:prstGeom>
         </p:spPr>
       </p:pic>
     </p:spTree>

</xml_diff>